<commit_message>
docs: align manuals and presentation with target architecture
</commit_message>
<xml_diff>
--- a/Harness-System.pptx
+++ b/Harness-System.pptx
@@ -14,6 +14,7 @@
     <p:sldId id="259" r:id="rId5"/>
     <p:sldId id="260" r:id="rId6"/>
     <p:sldId id="261" r:id="rId7"/>
+    <p:sldId id="262" r:id="rId13"/>
   </p:sldIdLst>
   <p:sldSz cx="12192000" cy="6858000"/>
   <p:notesSz cx="6858000" cy="9144000"/>
@@ -1236,6 +1237,96 @@
 </p:notes>
 </file>
 
+<file path=ppt/notesSlides/notesSlide7.xml><?xml version="1.0" encoding="utf-8"?>
+<p:notes xmlns:a="http://schemas.openxmlformats.org/drawingml/2006/main" xmlns:p="http://schemas.openxmlformats.org/presentationml/2006/main" xmlns:r="http://schemas.openxmlformats.org/officeDocument/2006/relationships">
+  <p:cSld>
+    <p:spTree>
+      <p:nvGrpSpPr>
+        <p:cNvPr id="1" name=""/>
+        <p:cNvGrpSpPr/>
+        <p:nvPr/>
+      </p:nvGrpSpPr>
+      <p:grpSpPr>
+        <a:xfrm>
+          <a:off x="0" y="0"/>
+          <a:ext cx="0" cy="0"/>
+          <a:chOff x="0" y="0"/>
+          <a:chExt cx="0" cy="0"/>
+        </a:xfrm>
+      </p:grpSpPr>
+      <p:sp>
+        <p:nvSpPr>
+          <p:cNvPr id="2" name="Slide Image Placeholder 1"/>
+          <p:cNvSpPr>
+            <a:spLocks noGrp="1"/>
+          </p:cNvSpPr>
+          <p:nvPr>
+            <p:ph type="sldImg" idx="2"/>
+          </p:nvPr>
+        </p:nvSpPr>
+        <p:spPr/>
+      </p:sp>
+      <p:sp>
+        <p:nvSpPr>
+          <p:cNvPr id="3" name="Notes Placeholder 2"/>
+          <p:cNvSpPr>
+            <a:spLocks noGrp="1"/>
+          </p:cNvSpPr>
+          <p:nvPr>
+            <p:ph type="body" idx="3" sz="quarter"/>
+          </p:nvPr>
+        </p:nvSpPr>
+        <p:spPr/>
+        <p:txBody>
+          <a:bodyPr/>
+          <a:lstStyle/>
+          <a:p>
+            <a:r>
+              <a:t>Vortragshinweise</a:t>
+            </a:r>
+          </a:p>
+          <a:p>
+            <a:r>
+              <a:t>• Die Folie trennt den bereits getesteten lokalen Stack von den noch offenen Zielarchitekturarbeiten.</a:t>
+            </a:r>
+          </a:p>
+          <a:p>
+            <a:r>
+              <a:t>• Der aktuelle CPU-Teststack beweist die Konfiguration, aber noch nicht die produktive GPU- und Host-Port-Architektur.</a:t>
+            </a:r>
+          </a:p>
+          <a:p>
+            <a:r>
+              <a:t>• Jeder Punkt benötigt einen Owner, einen Testnachweis und eine dokumentierte Freigabe.</a:t>
+            </a:r>
+          </a:p>
+          <a:p>
+            <a:r>
+              <a:t>• Das Harness muss vor dem Deployment als Pflichtgate erfolgreich sein.</a:t>
+            </a:r>
+          </a:p>
+        </p:txBody>
+      </p:sp>
+      <p:sp>
+        <p:nvSpPr>
+          <p:cNvPr id="4" name="Slide Number Placeholder 3"/>
+          <p:cNvSpPr>
+            <a:spLocks noGrp="1"/>
+          </p:cNvSpPr>
+          <p:nvPr>
+            <p:ph type="sldNum" idx="5" sz="quarter"/>
+          </p:nvPr>
+        </p:nvSpPr>
+        <p:spPr/>
+      </p:sp>
+    </p:spTree>
+  </p:cSld>
+  <p:clrMapOvr>
+    <a:masterClrMapping/>
+  </p:clrMapOvr>
+</p:notes>
+</file>
+
 <file path=ppt/slideLayouts/slideLayout1.xml><?xml version="1.0" encoding="utf-8"?>
 <p:sldLayout xmlns:a="http://schemas.openxmlformats.org/drawingml/2006/main" xmlns:r="http://schemas.openxmlformats.org/officeDocument/2006/relationships" xmlns:p="http://schemas.openxmlformats.org/presentationml/2006/main" type="title" preserve="1">
   <p:cSld name="Title Slide">
@@ -9051,6 +9142,351 @@
               </a:solidFill>
               <a:latin typeface="Aptos"/>
             </a:endParaRPr>
+          </a:p>
+        </p:txBody>
+      </p:sp>
+    </p:spTree>
+  </p:cSld>
+  <p:clrMapOvr>
+    <a:masterClrMapping/>
+  </p:clrMapOvr>
+</p:sld>
+</file>
+
+<file path=ppt/slides/slide7.xml><?xml version="1.0" encoding="utf-8"?>
+<p:sld xmlns:a="http://schemas.openxmlformats.org/drawingml/2006/main" xmlns:p="http://schemas.openxmlformats.org/presentationml/2006/main" xmlns:r="http://schemas.openxmlformats.org/officeDocument/2006/relationships">
+  <p:cSld>
+    <p:spTree>
+      <p:nvGrpSpPr>
+        <p:cNvPr id="1" name=""/>
+        <p:cNvGrpSpPr/>
+        <p:nvPr/>
+      </p:nvGrpSpPr>
+      <p:grpSpPr/>
+      <p:sp>
+        <p:nvSpPr>
+          <p:cNvPr id="2" name="Rectangle 1"/>
+          <p:cNvSpPr/>
+          <p:nvPr/>
+        </p:nvSpPr>
+        <p:spPr>
+          <a:xfrm>
+            <a:off x="0" y="0"/>
+            <a:ext cx="12191695" cy="146304"/>
+          </a:xfrm>
+          <a:prstGeom prst="rect">
+            <a:avLst/>
+          </a:prstGeom>
+          <a:solidFill>
+            <a:srgbClr val="206991"/>
+          </a:solidFill>
+          <a:ln>
+            <a:solidFill>
+              <a:srgbClr val="206991"/>
+            </a:solidFill>
+          </a:ln>
+        </p:spPr>
+        <p:style>
+          <a:lnRef idx="1">
+            <a:schemeClr val="accent1"/>
+          </a:lnRef>
+          <a:fillRef idx="3">
+            <a:schemeClr val="accent1"/>
+          </a:fillRef>
+          <a:effectRef idx="2">
+            <a:schemeClr val="accent1"/>
+          </a:effectRef>
+          <a:fontRef idx="minor">
+            <a:schemeClr val="lt1"/>
+          </a:fontRef>
+        </p:style>
+        <p:txBody>
+          <a:bodyPr rtlCol="0" anchor="ctr"/>
+          <a:lstStyle/>
+          <a:p>
+            <a:pPr algn="ctr"/>
+          </a:p>
+        </p:txBody>
+      </p:sp>
+      <p:sp>
+        <p:nvSpPr>
+          <p:cNvPr id="3" name="TextBox 2"/>
+          <p:cNvSpPr txBox="1"/>
+          <p:nvPr/>
+        </p:nvSpPr>
+        <p:spPr>
+          <a:xfrm>
+            <a:off x="640080" y="411480"/>
+            <a:ext cx="5486400" cy="274320"/>
+          </a:xfrm>
+          <a:prstGeom prst="rect">
+            <a:avLst/>
+          </a:prstGeom>
+          <a:noFill/>
+        </p:spPr>
+        <p:txBody>
+          <a:bodyPr wrap="square">
+            <a:spAutoFit/>
+          </a:bodyPr>
+          <a:lstStyle/>
+          <a:p>
+            <a:r>
+              <a:rPr sz="1200" b="1">
+                <a:solidFill>
+                  <a:srgbClr val="206991"/>
+                </a:solidFill>
+                <a:latin typeface="Aptos"/>
+              </a:rPr>
+              <a:t>ZIELARCHITEKTUR – OFFENE TO-DOS</a:t>
+            </a:r>
+          </a:p>
+        </p:txBody>
+      </p:sp>
+      <p:sp>
+        <p:nvSpPr>
+          <p:cNvPr id="4" name="TextBox 3"/>
+          <p:cNvSpPr txBox="1"/>
+          <p:nvPr/>
+        </p:nvSpPr>
+        <p:spPr>
+          <a:xfrm>
+            <a:off x="640080" y="822960"/>
+            <a:ext cx="10515600" cy="502920"/>
+          </a:xfrm>
+          <a:prstGeom prst="rect">
+            <a:avLst/>
+          </a:prstGeom>
+          <a:noFill/>
+        </p:spPr>
+        <p:txBody>
+          <a:bodyPr wrap="square">
+            <a:spAutoFit/>
+          </a:bodyPr>
+          <a:lstStyle/>
+          <a:p>
+            <a:r>
+              <a:rPr sz="2700" b="1">
+                <a:solidFill>
+                  <a:srgbClr val="122B40"/>
+                </a:solidFill>
+                <a:latin typeface="Aptos"/>
+              </a:rPr>
+              <a:t>Vom Harness-Test zur vollständigen Gateway-Architektur</a:t>
+            </a:r>
+          </a:p>
+        </p:txBody>
+      </p:sp>
+      <p:sp>
+        <p:nvSpPr>
+          <p:cNvPr id="5" name="TextBox 4"/>
+          <p:cNvSpPr txBox="1"/>
+          <p:nvPr/>
+        </p:nvSpPr>
+        <p:spPr>
+          <a:xfrm>
+            <a:off x="822960" y="1645920"/>
+            <a:ext cx="10515600" cy="4297680"/>
+          </a:xfrm>
+          <a:prstGeom prst="rect">
+            <a:avLst/>
+          </a:prstGeom>
+          <a:noFill/>
+        </p:spPr>
+        <p:txBody>
+          <a:bodyPr wrap="square">
+            <a:spAutoFit/>
+          </a:bodyPr>
+          <a:lstStyle/>
+          <a:p>
+            <a:pPr>
+              <a:spcAft>
+                <a:spcPts val="800"/>
+              </a:spcAft>
+              <a:defRPr sz="1600">
+                <a:solidFill>
+                  <a:srgbClr val="202B36"/>
+                </a:solidFill>
+                <a:latin typeface="Aptos"/>
+              </a:defRPr>
+            </a:pPr>
+            <a:r>
+              <a:t>• Nginx: produktives TLS 1.3, Authentifizierung, Rate Limiting und Host-Portfreigabe abschließen</a:t>
+            </a:r>
+          </a:p>
+          <a:p>
+            <a:pPr>
+              <a:spcAft>
+                <a:spcPts val="800"/>
+              </a:spcAft>
+              <a:defRPr sz="1600">
+                <a:solidFill>
+                  <a:srgbClr val="202B36"/>
+                </a:solidFill>
+                <a:latin typeface="Aptos"/>
+              </a:defRPr>
+            </a:pPr>
+            <a:r>
+              <a:t>• LiteLLM: ACLs, API-Keys, Token-Tracking und freigegebene Modellaliasse konfigurieren</a:t>
+            </a:r>
+          </a:p>
+          <a:p>
+            <a:pPr>
+              <a:spcAft>
+                <a:spcPts val="800"/>
+              </a:spcAft>
+              <a:defRPr sz="1600">
+                <a:solidFill>
+                  <a:srgbClr val="202B36"/>
+                </a:solidFill>
+                <a:latin typeface="Aptos"/>
+              </a:defRPr>
+            </a:pPr>
+            <a:r>
+              <a:t>• Ollama: RAG-/Coding-Instanzen mit getrennten Netzwerken, Volumes und Ressourcen bereitstellen</a:t>
+            </a:r>
+          </a:p>
+          <a:p>
+            <a:pPr>
+              <a:spcAft>
+                <a:spcPts val="800"/>
+              </a:spcAft>
+              <a:defRPr sz="1600">
+                <a:solidFill>
+                  <a:srgbClr val="202B36"/>
+                </a:solidFill>
+                <a:latin typeface="Aptos"/>
+              </a:defRPr>
+            </a:pPr>
+            <a:r>
+              <a:t>• GPU/ROCm auf dem Zielsystem nachweisen oder verbindliches CPU-Betriebsprofil freigeben</a:t>
+            </a:r>
+          </a:p>
+          <a:p>
+            <a:pPr>
+              <a:spcAft>
+                <a:spcPts val="800"/>
+              </a:spcAft>
+              <a:defRPr sz="1600">
+                <a:solidFill>
+                  <a:srgbClr val="202B36"/>
+                </a:solidFill>
+                <a:latin typeface="Aptos"/>
+              </a:defRPr>
+            </a:pPr>
+            <a:r>
+              <a:t>• FastMCP ausschließlich über LiteLLM routen; direkten LM-Studio-Fallback entfernen</a:t>
+            </a:r>
+          </a:p>
+          <a:p>
+            <a:pPr>
+              <a:spcAft>
+                <a:spcPts val="800"/>
+              </a:spcAft>
+              <a:defRPr sz="1600">
+                <a:solidFill>
+                  <a:srgbClr val="202B36"/>
+                </a:solidFill>
+                <a:latin typeface="Aptos"/>
+              </a:defRPr>
+            </a:pPr>
+            <a:r>
+              <a:t>• Harness als CI-/GitOps-Pflichtgate mit PII-Scan, Evaluation und Evidence Bundle verankern</a:t>
+            </a:r>
+          </a:p>
+          <a:p>
+            <a:pPr>
+              <a:spcAft>
+                <a:spcPts val="800"/>
+              </a:spcAft>
+              <a:defRPr sz="1600">
+                <a:solidFill>
+                  <a:srgbClr val="202B36"/>
+                </a:solidFill>
+                <a:latin typeface="Aptos"/>
+              </a:defRPr>
+            </a:pPr>
+            <a:r>
+              <a:t>• Governance: Owner, Rechtsprüfung, Retention und Human-Oversight-Nachweise abschließen</a:t>
+            </a:r>
+          </a:p>
+        </p:txBody>
+      </p:sp>
+      <p:sp>
+        <p:nvSpPr>
+          <p:cNvPr id="6" name="Rounded Rectangle 5"/>
+          <p:cNvSpPr/>
+          <p:nvPr/>
+        </p:nvSpPr>
+        <p:spPr>
+          <a:xfrm>
+            <a:off x="822960" y="5806440"/>
+            <a:ext cx="10515600" cy="502920"/>
+          </a:xfrm>
+          <a:prstGeom prst="roundRect">
+            <a:avLst/>
+          </a:prstGeom>
+          <a:solidFill>
+            <a:srgbClr val="122B40"/>
+          </a:solidFill>
+          <a:ln>
+            <a:solidFill>
+              <a:srgbClr val="122B40"/>
+            </a:solidFill>
+          </a:ln>
+        </p:spPr>
+        <p:style>
+          <a:lnRef idx="1">
+            <a:schemeClr val="accent1"/>
+          </a:lnRef>
+          <a:fillRef idx="3">
+            <a:schemeClr val="accent1"/>
+          </a:fillRef>
+          <a:effectRef idx="2">
+            <a:schemeClr val="accent1"/>
+          </a:effectRef>
+          <a:fontRef idx="minor">
+            <a:schemeClr val="lt1"/>
+          </a:fontRef>
+        </p:style>
+        <p:txBody>
+          <a:bodyPr rtlCol="0" anchor="ctr"/>
+          <a:lstStyle/>
+          <a:p>
+            <a:pPr algn="ctr"/>
+          </a:p>
+        </p:txBody>
+      </p:sp>
+      <p:sp>
+        <p:nvSpPr>
+          <p:cNvPr id="7" name="TextBox 6"/>
+          <p:cNvSpPr txBox="1"/>
+          <p:nvPr/>
+        </p:nvSpPr>
+        <p:spPr>
+          <a:xfrm>
+            <a:off x="1097280" y="5961888"/>
+            <a:ext cx="9966960" cy="182880"/>
+          </a:xfrm>
+          <a:prstGeom prst="rect">
+            <a:avLst/>
+          </a:prstGeom>
+          <a:noFill/>
+        </p:spPr>
+        <p:txBody>
+          <a:bodyPr wrap="square">
+            <a:spAutoFit/>
+          </a:bodyPr>
+          <a:lstStyle/>
+          <a:p>
+            <a:r>
+              <a:rPr sz="1300" b="1">
+                <a:solidFill>
+                  <a:srgbClr val="FFFFFF"/>
+                </a:solidFill>
+                <a:latin typeface="Aptos"/>
+              </a:rPr>
+              <a:t>Freigabe erst nach erfolgreichem End-to-End-Test und menschlicher Architektur-/Governance-Freigabe.</a:t>
+            </a:r>
           </a:p>
         </p:txBody>
       </p:sp>

</xml_diff>

<commit_message>
docs: add orchestrator and evaluation model
</commit_message>
<xml_diff>
--- a/Harness-System.pptx
+++ b/Harness-System.pptx
@@ -15,6 +15,7 @@
     <p:sldId id="260" r:id="rId6"/>
     <p:sldId id="261" r:id="rId7"/>
     <p:sldId id="262" r:id="rId13"/>
+    <p:sldId id="263" r:id="rId14"/>
   </p:sldIdLst>
   <p:sldSz cx="12192000" cy="6858000"/>
   <p:notesSz cx="6858000" cy="9144000"/>
@@ -1327,6 +1328,96 @@
 </p:notes>
 </file>
 
+<file path=ppt/notesSlides/notesSlide8.xml><?xml version="1.0" encoding="utf-8"?>
+<p:notes xmlns:a="http://schemas.openxmlformats.org/drawingml/2006/main" xmlns:p="http://schemas.openxmlformats.org/presentationml/2006/main" xmlns:r="http://schemas.openxmlformats.org/officeDocument/2006/relationships">
+  <p:cSld>
+    <p:spTree>
+      <p:nvGrpSpPr>
+        <p:cNvPr id="1" name=""/>
+        <p:cNvGrpSpPr/>
+        <p:nvPr/>
+      </p:nvGrpSpPr>
+      <p:grpSpPr>
+        <a:xfrm>
+          <a:off x="0" y="0"/>
+          <a:ext cx="0" cy="0"/>
+          <a:chOff x="0" y="0"/>
+          <a:chExt cx="0" cy="0"/>
+        </a:xfrm>
+      </p:grpSpPr>
+      <p:sp>
+        <p:nvSpPr>
+          <p:cNvPr id="2" name="Slide Image Placeholder 1"/>
+          <p:cNvSpPr>
+            <a:spLocks noGrp="1"/>
+          </p:cNvSpPr>
+          <p:nvPr>
+            <p:ph type="sldImg" idx="2"/>
+          </p:nvPr>
+        </p:nvSpPr>
+        <p:spPr/>
+      </p:sp>
+      <p:sp>
+        <p:nvSpPr>
+          <p:cNvPr id="3" name="Notes Placeholder 2"/>
+          <p:cNvSpPr>
+            <a:spLocks noGrp="1"/>
+          </p:cNvSpPr>
+          <p:nvPr>
+            <p:ph type="body" idx="3" sz="quarter"/>
+          </p:nvPr>
+        </p:nvSpPr>
+        <p:spPr/>
+        <p:txBody>
+          <a:bodyPr/>
+          <a:lstStyle/>
+          <a:p>
+            <a:r>
+              <a:t>Vortragshinweise</a:t>
+            </a:r>
+          </a:p>
+          <a:p>
+            <a:r>
+              <a:t>• Die Harness orchestriert Tests und technische Kontrollen, bewertet aber nicht unabhängig die Qualität der LLM-Ausgabe.</a:t>
+            </a:r>
+          </a:p>
+          <a:p>
+            <a:r>
+              <a:t>• Datensätze und erwartete Ergebnisse müssen versioniert und PII-bereinigt werden.</a:t>
+            </a:r>
+          </a:p>
+          <a:p>
+            <a:r>
+              <a:t>• Die Evaluation-Suite benötigt unabhängige Grader für Sicherheit, Qualität, Datenschutz und No-Mutation.</a:t>
+            </a:r>
+          </a:p>
+          <a:p>
+            <a:r>
+              <a:t>• Erst das Evidence Bundle verbindet Testfall, Modell, Policy, Ergebnis und menschliche Freigabe.</a:t>
+            </a:r>
+          </a:p>
+        </p:txBody>
+      </p:sp>
+      <p:sp>
+        <p:nvSpPr>
+          <p:cNvPr id="4" name="Slide Number Placeholder 3"/>
+          <p:cNvSpPr>
+            <a:spLocks noGrp="1"/>
+          </p:cNvSpPr>
+          <p:nvPr>
+            <p:ph type="sldNum" idx="5" sz="quarter"/>
+          </p:nvPr>
+        </p:nvSpPr>
+        <p:spPr/>
+      </p:sp>
+    </p:spTree>
+  </p:cSld>
+  <p:clrMapOvr>
+    <a:masterClrMapping/>
+  </p:clrMapOvr>
+</p:notes>
+</file>
+
 <file path=ppt/slideLayouts/slideLayout1.xml><?xml version="1.0" encoding="utf-8"?>
 <p:sldLayout xmlns:a="http://schemas.openxmlformats.org/drawingml/2006/main" xmlns:r="http://schemas.openxmlformats.org/officeDocument/2006/relationships" xmlns:p="http://schemas.openxmlformats.org/presentationml/2006/main" type="title" preserve="1">
   <p:cSld name="Title Slide">
@@ -9486,6 +9577,999 @@
                 <a:latin typeface="Aptos"/>
               </a:rPr>
               <a:t>Freigabe erst nach erfolgreichem End-to-End-Test und menschlicher Architektur-/Governance-Freigabe.</a:t>
+            </a:r>
+          </a:p>
+        </p:txBody>
+      </p:sp>
+    </p:spTree>
+  </p:cSld>
+  <p:clrMapOvr>
+    <a:masterClrMapping/>
+  </p:clrMapOvr>
+</p:sld>
+</file>
+
+<file path=ppt/slides/slide8.xml><?xml version="1.0" encoding="utf-8"?>
+<p:sld xmlns:a="http://schemas.openxmlformats.org/drawingml/2006/main" xmlns:p="http://schemas.openxmlformats.org/presentationml/2006/main" xmlns:r="http://schemas.openxmlformats.org/officeDocument/2006/relationships">
+  <p:cSld>
+    <p:spTree>
+      <p:nvGrpSpPr>
+        <p:cNvPr id="1" name=""/>
+        <p:cNvGrpSpPr/>
+        <p:nvPr/>
+      </p:nvGrpSpPr>
+      <p:grpSpPr/>
+      <p:sp>
+        <p:nvSpPr>
+          <p:cNvPr id="2" name="Rectangle 1"/>
+          <p:cNvSpPr/>
+          <p:nvPr/>
+        </p:nvSpPr>
+        <p:spPr>
+          <a:xfrm>
+            <a:off x="0" y="0"/>
+            <a:ext cx="12191695" cy="146304"/>
+          </a:xfrm>
+          <a:prstGeom prst="rect">
+            <a:avLst/>
+          </a:prstGeom>
+          <a:solidFill>
+            <a:srgbClr val="206991"/>
+          </a:solidFill>
+          <a:ln>
+            <a:solidFill>
+              <a:srgbClr val="206991"/>
+            </a:solidFill>
+          </a:ln>
+        </p:spPr>
+        <p:style>
+          <a:lnRef idx="1">
+            <a:schemeClr val="accent1"/>
+          </a:lnRef>
+          <a:fillRef idx="3">
+            <a:schemeClr val="accent1"/>
+          </a:fillRef>
+          <a:effectRef idx="2">
+            <a:schemeClr val="accent1"/>
+          </a:effectRef>
+          <a:fontRef idx="minor">
+            <a:schemeClr val="lt1"/>
+          </a:fontRef>
+        </p:style>
+        <p:txBody>
+          <a:bodyPr rtlCol="0" anchor="ctr"/>
+          <a:lstStyle/>
+          <a:p>
+            <a:pPr algn="ctr"/>
+          </a:p>
+        </p:txBody>
+      </p:sp>
+      <p:sp>
+        <p:nvSpPr>
+          <p:cNvPr id="3" name="TextBox 2"/>
+          <p:cNvSpPr txBox="1"/>
+          <p:nvPr/>
+        </p:nvSpPr>
+        <p:spPr>
+          <a:xfrm>
+            <a:off x="594360" y="347472"/>
+            <a:ext cx="2743200" cy="228600"/>
+          </a:xfrm>
+          <a:prstGeom prst="rect">
+            <a:avLst/>
+          </a:prstGeom>
+          <a:noFill/>
+        </p:spPr>
+        <p:txBody>
+          <a:bodyPr wrap="square">
+            <a:spAutoFit/>
+          </a:bodyPr>
+          <a:lstStyle/>
+          <a:p>
+            <a:pPr algn="l"/>
+            <a:r>
+              <a:rPr sz="1000" b="1">
+                <a:solidFill>
+                  <a:srgbClr val="206991"/>
+                </a:solidFill>
+                <a:latin typeface="Aptos"/>
+              </a:rPr>
+              <a:t>TESTMODELL</a:t>
+            </a:r>
+          </a:p>
+        </p:txBody>
+      </p:sp>
+      <p:sp>
+        <p:nvSpPr>
+          <p:cNvPr id="4" name="TextBox 3"/>
+          <p:cNvSpPr txBox="1"/>
+          <p:nvPr/>
+        </p:nvSpPr>
+        <p:spPr>
+          <a:xfrm>
+            <a:off x="594360" y="658368"/>
+            <a:ext cx="10515600" cy="548640"/>
+          </a:xfrm>
+          <a:prstGeom prst="rect">
+            <a:avLst/>
+          </a:prstGeom>
+          <a:noFill/>
+        </p:spPr>
+        <p:txBody>
+          <a:bodyPr wrap="square">
+            <a:spAutoFit/>
+          </a:bodyPr>
+          <a:lstStyle/>
+          <a:p>
+            <a:pPr algn="l"/>
+            <a:r>
+              <a:rPr sz="2700" b="1">
+                <a:solidFill>
+                  <a:srgbClr val="122B40"/>
+                </a:solidFill>
+                <a:latin typeface="Aptos"/>
+              </a:rPr>
+              <a:t>Orchestrator ist nicht der Richter</a:t>
+            </a:r>
+          </a:p>
+        </p:txBody>
+      </p:sp>
+      <p:sp>
+        <p:nvSpPr>
+          <p:cNvPr id="5" name="Rounded Rectangle 4"/>
+          <p:cNvSpPr/>
+          <p:nvPr/>
+        </p:nvSpPr>
+        <p:spPr>
+          <a:xfrm>
+            <a:off x="685800" y="1828800"/>
+            <a:ext cx="2423160" cy="1645920"/>
+          </a:xfrm>
+          <a:prstGeom prst="roundRect">
+            <a:avLst/>
+          </a:prstGeom>
+          <a:solidFill>
+            <a:srgbClr val="EFF5F7"/>
+          </a:solidFill>
+          <a:ln>
+            <a:solidFill>
+              <a:srgbClr val="EFF5F7"/>
+            </a:solidFill>
+          </a:ln>
+        </p:spPr>
+        <p:style>
+          <a:lnRef idx="1">
+            <a:schemeClr val="accent1"/>
+          </a:lnRef>
+          <a:fillRef idx="3">
+            <a:schemeClr val="accent1"/>
+          </a:fillRef>
+          <a:effectRef idx="2">
+            <a:schemeClr val="accent1"/>
+          </a:effectRef>
+          <a:fontRef idx="minor">
+            <a:schemeClr val="lt1"/>
+          </a:fontRef>
+        </p:style>
+        <p:txBody>
+          <a:bodyPr rtlCol="0" anchor="ctr"/>
+          <a:lstStyle/>
+          <a:p>
+            <a:pPr algn="ctr"/>
+          </a:p>
+        </p:txBody>
+      </p:sp>
+      <p:sp>
+        <p:nvSpPr>
+          <p:cNvPr id="6" name="Rectangle 5"/>
+          <p:cNvSpPr/>
+          <p:nvPr/>
+        </p:nvSpPr>
+        <p:spPr>
+          <a:xfrm>
+            <a:off x="685800" y="1828800"/>
+            <a:ext cx="2423160" cy="109728"/>
+          </a:xfrm>
+          <a:prstGeom prst="rect">
+            <a:avLst/>
+          </a:prstGeom>
+          <a:solidFill>
+            <a:srgbClr val="206991"/>
+          </a:solidFill>
+          <a:ln>
+            <a:solidFill>
+              <a:srgbClr val="206991"/>
+            </a:solidFill>
+          </a:ln>
+        </p:spPr>
+        <p:style>
+          <a:lnRef idx="1">
+            <a:schemeClr val="accent1"/>
+          </a:lnRef>
+          <a:fillRef idx="3">
+            <a:schemeClr val="accent1"/>
+          </a:fillRef>
+          <a:effectRef idx="2">
+            <a:schemeClr val="accent1"/>
+          </a:effectRef>
+          <a:fontRef idx="minor">
+            <a:schemeClr val="lt1"/>
+          </a:fontRef>
+        </p:style>
+        <p:txBody>
+          <a:bodyPr rtlCol="0" anchor="ctr"/>
+          <a:lstStyle/>
+          <a:p>
+            <a:pPr algn="ctr"/>
+          </a:p>
+        </p:txBody>
+      </p:sp>
+      <p:sp>
+        <p:nvSpPr>
+          <p:cNvPr id="7" name="TextBox 6"/>
+          <p:cNvSpPr txBox="1"/>
+          <p:nvPr/>
+        </p:nvSpPr>
+        <p:spPr>
+          <a:xfrm>
+            <a:off x="868680" y="2148840"/>
+            <a:ext cx="2057400" cy="320040"/>
+          </a:xfrm>
+          <a:prstGeom prst="rect">
+            <a:avLst/>
+          </a:prstGeom>
+          <a:noFill/>
+        </p:spPr>
+        <p:txBody>
+          <a:bodyPr wrap="square">
+            <a:spAutoFit/>
+          </a:bodyPr>
+          <a:lstStyle/>
+          <a:p>
+            <a:pPr algn="ctr"/>
+            <a:r>
+              <a:rPr sz="1400" b="1">
+                <a:solidFill>
+                  <a:srgbClr val="122B40"/>
+                </a:solidFill>
+                <a:latin typeface="Aptos"/>
+              </a:rPr>
+              <a:t>Datensatz-Pipeline</a:t>
+            </a:r>
+          </a:p>
+        </p:txBody>
+      </p:sp>
+      <p:sp>
+        <p:nvSpPr>
+          <p:cNvPr id="8" name="TextBox 7"/>
+          <p:cNvSpPr txBox="1"/>
+          <p:nvPr/>
+        </p:nvSpPr>
+        <p:spPr>
+          <a:xfrm>
+            <a:off x="868680" y="2697480"/>
+            <a:ext cx="2057400" cy="502920"/>
+          </a:xfrm>
+          <a:prstGeom prst="rect">
+            <a:avLst/>
+          </a:prstGeom>
+          <a:noFill/>
+        </p:spPr>
+        <p:txBody>
+          <a:bodyPr wrap="square">
+            <a:spAutoFit/>
+          </a:bodyPr>
+          <a:lstStyle/>
+          <a:p>
+            <a:pPr algn="ctr"/>
+            <a:r>
+              <a:rPr sz="1100" b="0">
+                <a:solidFill>
+                  <a:srgbClr val="202B36"/>
+                </a:solidFill>
+                <a:latin typeface="Aptos"/>
+              </a:rPr>
+              <a:t>versionierte Fixtures und erwartete Ergebnisse</a:t>
+            </a:r>
+          </a:p>
+        </p:txBody>
+      </p:sp>
+      <p:sp>
+        <p:nvSpPr>
+          <p:cNvPr id="9" name="TextBox 8"/>
+          <p:cNvSpPr txBox="1"/>
+          <p:nvPr/>
+        </p:nvSpPr>
+        <p:spPr>
+          <a:xfrm>
+            <a:off x="3172968" y="2423160"/>
+            <a:ext cx="320040" cy="320040"/>
+          </a:xfrm>
+          <a:prstGeom prst="rect">
+            <a:avLst/>
+          </a:prstGeom>
+          <a:noFill/>
+        </p:spPr>
+        <p:txBody>
+          <a:bodyPr wrap="square">
+            <a:spAutoFit/>
+          </a:bodyPr>
+          <a:lstStyle/>
+          <a:p>
+            <a:pPr algn="ctr"/>
+            <a:r>
+              <a:rPr sz="2400" b="1">
+                <a:solidFill>
+                  <a:srgbClr val="206991"/>
+                </a:solidFill>
+                <a:latin typeface="Aptos"/>
+              </a:rPr>
+              <a:t>→</a:t>
+            </a:r>
+          </a:p>
+        </p:txBody>
+      </p:sp>
+      <p:sp>
+        <p:nvSpPr>
+          <p:cNvPr id="10" name="Rounded Rectangle 9"/>
+          <p:cNvSpPr/>
+          <p:nvPr/>
+        </p:nvSpPr>
+        <p:spPr>
+          <a:xfrm>
+            <a:off x="3520440" y="1828800"/>
+            <a:ext cx="2423160" cy="1645920"/>
+          </a:xfrm>
+          <a:prstGeom prst="roundRect">
+            <a:avLst/>
+          </a:prstGeom>
+          <a:solidFill>
+            <a:srgbClr val="EFF5F7"/>
+          </a:solidFill>
+          <a:ln>
+            <a:solidFill>
+              <a:srgbClr val="EFF5F7"/>
+            </a:solidFill>
+          </a:ln>
+        </p:spPr>
+        <p:style>
+          <a:lnRef idx="1">
+            <a:schemeClr val="accent1"/>
+          </a:lnRef>
+          <a:fillRef idx="3">
+            <a:schemeClr val="accent1"/>
+          </a:fillRef>
+          <a:effectRef idx="2">
+            <a:schemeClr val="accent1"/>
+          </a:effectRef>
+          <a:fontRef idx="minor">
+            <a:schemeClr val="lt1"/>
+          </a:fontRef>
+        </p:style>
+        <p:txBody>
+          <a:bodyPr rtlCol="0" anchor="ctr"/>
+          <a:lstStyle/>
+          <a:p>
+            <a:pPr algn="ctr"/>
+          </a:p>
+        </p:txBody>
+      </p:sp>
+      <p:sp>
+        <p:nvSpPr>
+          <p:cNvPr id="11" name="Rectangle 10"/>
+          <p:cNvSpPr/>
+          <p:nvPr/>
+        </p:nvSpPr>
+        <p:spPr>
+          <a:xfrm>
+            <a:off x="3520440" y="1828800"/>
+            <a:ext cx="2423160" cy="109728"/>
+          </a:xfrm>
+          <a:prstGeom prst="rect">
+            <a:avLst/>
+          </a:prstGeom>
+          <a:solidFill>
+            <a:srgbClr val="00897B"/>
+          </a:solidFill>
+          <a:ln>
+            <a:solidFill>
+              <a:srgbClr val="00897B"/>
+            </a:solidFill>
+          </a:ln>
+        </p:spPr>
+        <p:style>
+          <a:lnRef idx="1">
+            <a:schemeClr val="accent1"/>
+          </a:lnRef>
+          <a:fillRef idx="3">
+            <a:schemeClr val="accent1"/>
+          </a:fillRef>
+          <a:effectRef idx="2">
+            <a:schemeClr val="accent1"/>
+          </a:effectRef>
+          <a:fontRef idx="minor">
+            <a:schemeClr val="lt1"/>
+          </a:fontRef>
+        </p:style>
+        <p:txBody>
+          <a:bodyPr rtlCol="0" anchor="ctr"/>
+          <a:lstStyle/>
+          <a:p>
+            <a:pPr algn="ctr"/>
+          </a:p>
+        </p:txBody>
+      </p:sp>
+      <p:sp>
+        <p:nvSpPr>
+          <p:cNvPr id="12" name="TextBox 11"/>
+          <p:cNvSpPr txBox="1"/>
+          <p:nvPr/>
+        </p:nvSpPr>
+        <p:spPr>
+          <a:xfrm>
+            <a:off x="3703320" y="2148840"/>
+            <a:ext cx="2057400" cy="320040"/>
+          </a:xfrm>
+          <a:prstGeom prst="rect">
+            <a:avLst/>
+          </a:prstGeom>
+          <a:noFill/>
+        </p:spPr>
+        <p:txBody>
+          <a:bodyPr wrap="square">
+            <a:spAutoFit/>
+          </a:bodyPr>
+          <a:lstStyle/>
+          <a:p>
+            <a:pPr algn="ctr"/>
+            <a:r>
+              <a:rPr sz="1400" b="1">
+                <a:solidFill>
+                  <a:srgbClr val="122B40"/>
+                </a:solidFill>
+                <a:latin typeface="Aptos"/>
+              </a:rPr>
+              <a:t>Harness-Orchestrator</a:t>
+            </a:r>
+          </a:p>
+        </p:txBody>
+      </p:sp>
+      <p:sp>
+        <p:nvSpPr>
+          <p:cNvPr id="13" name="TextBox 12"/>
+          <p:cNvSpPr txBox="1"/>
+          <p:nvPr/>
+        </p:nvSpPr>
+        <p:spPr>
+          <a:xfrm>
+            <a:off x="3703320" y="2697480"/>
+            <a:ext cx="2057400" cy="502920"/>
+          </a:xfrm>
+          <a:prstGeom prst="rect">
+            <a:avLst/>
+          </a:prstGeom>
+          <a:noFill/>
+        </p:spPr>
+        <p:txBody>
+          <a:bodyPr wrap="square">
+            <a:spAutoFit/>
+          </a:bodyPr>
+          <a:lstStyle/>
+          <a:p>
+            <a:pPr algn="ctr"/>
+            <a:r>
+              <a:rPr sz="1100" b="0">
+                <a:solidFill>
+                  <a:srgbClr val="202B36"/>
+                </a:solidFill>
+                <a:latin typeface="Aptos"/>
+              </a:rPr>
+              <a:t>Scope, Tools, Gates und sichere Ausführung</a:t>
+            </a:r>
+          </a:p>
+        </p:txBody>
+      </p:sp>
+      <p:sp>
+        <p:nvSpPr>
+          <p:cNvPr id="14" name="TextBox 13"/>
+          <p:cNvSpPr txBox="1"/>
+          <p:nvPr/>
+        </p:nvSpPr>
+        <p:spPr>
+          <a:xfrm>
+            <a:off x="6007608" y="2423160"/>
+            <a:ext cx="320040" cy="320040"/>
+          </a:xfrm>
+          <a:prstGeom prst="rect">
+            <a:avLst/>
+          </a:prstGeom>
+          <a:noFill/>
+        </p:spPr>
+        <p:txBody>
+          <a:bodyPr wrap="square">
+            <a:spAutoFit/>
+          </a:bodyPr>
+          <a:lstStyle/>
+          <a:p>
+            <a:pPr algn="ctr"/>
+            <a:r>
+              <a:rPr sz="2400" b="1">
+                <a:solidFill>
+                  <a:srgbClr val="206991"/>
+                </a:solidFill>
+                <a:latin typeface="Aptos"/>
+              </a:rPr>
+              <a:t>→</a:t>
+            </a:r>
+          </a:p>
+        </p:txBody>
+      </p:sp>
+      <p:sp>
+        <p:nvSpPr>
+          <p:cNvPr id="15" name="Rounded Rectangle 14"/>
+          <p:cNvSpPr/>
+          <p:nvPr/>
+        </p:nvSpPr>
+        <p:spPr>
+          <a:xfrm>
+            <a:off x="6355080" y="1828800"/>
+            <a:ext cx="2423160" cy="1645920"/>
+          </a:xfrm>
+          <a:prstGeom prst="roundRect">
+            <a:avLst/>
+          </a:prstGeom>
+          <a:solidFill>
+            <a:srgbClr val="EFF5F7"/>
+          </a:solidFill>
+          <a:ln>
+            <a:solidFill>
+              <a:srgbClr val="EFF5F7"/>
+            </a:solidFill>
+          </a:ln>
+        </p:spPr>
+        <p:style>
+          <a:lnRef idx="1">
+            <a:schemeClr val="accent1"/>
+          </a:lnRef>
+          <a:fillRef idx="3">
+            <a:schemeClr val="accent1"/>
+          </a:fillRef>
+          <a:effectRef idx="2">
+            <a:schemeClr val="accent1"/>
+          </a:effectRef>
+          <a:fontRef idx="minor">
+            <a:schemeClr val="lt1"/>
+          </a:fontRef>
+        </p:style>
+        <p:txBody>
+          <a:bodyPr rtlCol="0" anchor="ctr"/>
+          <a:lstStyle/>
+          <a:p>
+            <a:pPr algn="ctr"/>
+          </a:p>
+        </p:txBody>
+      </p:sp>
+      <p:sp>
+        <p:nvSpPr>
+          <p:cNvPr id="16" name="Rectangle 15"/>
+          <p:cNvSpPr/>
+          <p:nvPr/>
+        </p:nvSpPr>
+        <p:spPr>
+          <a:xfrm>
+            <a:off x="6355080" y="1828800"/>
+            <a:ext cx="2423160" cy="109728"/>
+          </a:xfrm>
+          <a:prstGeom prst="rect">
+            <a:avLst/>
+          </a:prstGeom>
+          <a:solidFill>
+            <a:srgbClr val="DA9420"/>
+          </a:solidFill>
+          <a:ln>
+            <a:solidFill>
+              <a:srgbClr val="DA9420"/>
+            </a:solidFill>
+          </a:ln>
+        </p:spPr>
+        <p:style>
+          <a:lnRef idx="1">
+            <a:schemeClr val="accent1"/>
+          </a:lnRef>
+          <a:fillRef idx="3">
+            <a:schemeClr val="accent1"/>
+          </a:fillRef>
+          <a:effectRef idx="2">
+            <a:schemeClr val="accent1"/>
+          </a:effectRef>
+          <a:fontRef idx="minor">
+            <a:schemeClr val="lt1"/>
+          </a:fontRef>
+        </p:style>
+        <p:txBody>
+          <a:bodyPr rtlCol="0" anchor="ctr"/>
+          <a:lstStyle/>
+          <a:p>
+            <a:pPr algn="ctr"/>
+          </a:p>
+        </p:txBody>
+      </p:sp>
+      <p:sp>
+        <p:nvSpPr>
+          <p:cNvPr id="17" name="TextBox 16"/>
+          <p:cNvSpPr txBox="1"/>
+          <p:nvPr/>
+        </p:nvSpPr>
+        <p:spPr>
+          <a:xfrm>
+            <a:off x="6537960" y="2148840"/>
+            <a:ext cx="2057400" cy="320040"/>
+          </a:xfrm>
+          <a:prstGeom prst="rect">
+            <a:avLst/>
+          </a:prstGeom>
+          <a:noFill/>
+        </p:spPr>
+        <p:txBody>
+          <a:bodyPr wrap="square">
+            <a:spAutoFit/>
+          </a:bodyPr>
+          <a:lstStyle/>
+          <a:p>
+            <a:pPr algn="ctr"/>
+            <a:r>
+              <a:rPr sz="1400" b="1">
+                <a:solidFill>
+                  <a:srgbClr val="122B40"/>
+                </a:solidFill>
+                <a:latin typeface="Aptos"/>
+              </a:rPr>
+              <a:t>LLM / Applikation</a:t>
+            </a:r>
+          </a:p>
+        </p:txBody>
+      </p:sp>
+      <p:sp>
+        <p:nvSpPr>
+          <p:cNvPr id="18" name="TextBox 17"/>
+          <p:cNvSpPr txBox="1"/>
+          <p:nvPr/>
+        </p:nvSpPr>
+        <p:spPr>
+          <a:xfrm>
+            <a:off x="6537960" y="2697480"/>
+            <a:ext cx="2057400" cy="502920"/>
+          </a:xfrm>
+          <a:prstGeom prst="rect">
+            <a:avLst/>
+          </a:prstGeom>
+          <a:noFill/>
+        </p:spPr>
+        <p:txBody>
+          <a:bodyPr wrap="square">
+            <a:spAutoFit/>
+          </a:bodyPr>
+          <a:lstStyle/>
+          <a:p>
+            <a:pPr algn="ctr"/>
+            <a:r>
+              <a:rPr sz="1100" b="0">
+                <a:solidFill>
+                  <a:srgbClr val="202B36"/>
+                </a:solidFill>
+                <a:latin typeface="Aptos"/>
+              </a:rPr>
+              <a:t>FastMCP, Gateway und Modellantwort</a:t>
+            </a:r>
+          </a:p>
+        </p:txBody>
+      </p:sp>
+      <p:sp>
+        <p:nvSpPr>
+          <p:cNvPr id="19" name="TextBox 18"/>
+          <p:cNvSpPr txBox="1"/>
+          <p:nvPr/>
+        </p:nvSpPr>
+        <p:spPr>
+          <a:xfrm>
+            <a:off x="8842248" y="2423160"/>
+            <a:ext cx="320040" cy="320040"/>
+          </a:xfrm>
+          <a:prstGeom prst="rect">
+            <a:avLst/>
+          </a:prstGeom>
+          <a:noFill/>
+        </p:spPr>
+        <p:txBody>
+          <a:bodyPr wrap="square">
+            <a:spAutoFit/>
+          </a:bodyPr>
+          <a:lstStyle/>
+          <a:p>
+            <a:pPr algn="ctr"/>
+            <a:r>
+              <a:rPr sz="2400" b="1">
+                <a:solidFill>
+                  <a:srgbClr val="206991"/>
+                </a:solidFill>
+                <a:latin typeface="Aptos"/>
+              </a:rPr>
+              <a:t>→</a:t>
+            </a:r>
+          </a:p>
+        </p:txBody>
+      </p:sp>
+      <p:sp>
+        <p:nvSpPr>
+          <p:cNvPr id="20" name="Rounded Rectangle 19"/>
+          <p:cNvSpPr/>
+          <p:nvPr/>
+        </p:nvSpPr>
+        <p:spPr>
+          <a:xfrm>
+            <a:off x="9189720" y="1828800"/>
+            <a:ext cx="2423160" cy="1645920"/>
+          </a:xfrm>
+          <a:prstGeom prst="roundRect">
+            <a:avLst/>
+          </a:prstGeom>
+          <a:solidFill>
+            <a:srgbClr val="EFF5F7"/>
+          </a:solidFill>
+          <a:ln>
+            <a:solidFill>
+              <a:srgbClr val="EFF5F7"/>
+            </a:solidFill>
+          </a:ln>
+        </p:spPr>
+        <p:style>
+          <a:lnRef idx="1">
+            <a:schemeClr val="accent1"/>
+          </a:lnRef>
+          <a:fillRef idx="3">
+            <a:schemeClr val="accent1"/>
+          </a:fillRef>
+          <a:effectRef idx="2">
+            <a:schemeClr val="accent1"/>
+          </a:effectRef>
+          <a:fontRef idx="minor">
+            <a:schemeClr val="lt1"/>
+          </a:fontRef>
+        </p:style>
+        <p:txBody>
+          <a:bodyPr rtlCol="0" anchor="ctr"/>
+          <a:lstStyle/>
+          <a:p>
+            <a:pPr algn="ctr"/>
+          </a:p>
+        </p:txBody>
+      </p:sp>
+      <p:sp>
+        <p:nvSpPr>
+          <p:cNvPr id="21" name="Rectangle 20"/>
+          <p:cNvSpPr/>
+          <p:nvPr/>
+        </p:nvSpPr>
+        <p:spPr>
+          <a:xfrm>
+            <a:off x="9189720" y="1828800"/>
+            <a:ext cx="2423160" cy="109728"/>
+          </a:xfrm>
+          <a:prstGeom prst="rect">
+            <a:avLst/>
+          </a:prstGeom>
+          <a:solidFill>
+            <a:srgbClr val="B23E3E"/>
+          </a:solidFill>
+          <a:ln>
+            <a:solidFill>
+              <a:srgbClr val="B23E3E"/>
+            </a:solidFill>
+          </a:ln>
+        </p:spPr>
+        <p:style>
+          <a:lnRef idx="1">
+            <a:schemeClr val="accent1"/>
+          </a:lnRef>
+          <a:fillRef idx="3">
+            <a:schemeClr val="accent1"/>
+          </a:fillRef>
+          <a:effectRef idx="2">
+            <a:schemeClr val="accent1"/>
+          </a:effectRef>
+          <a:fontRef idx="minor">
+            <a:schemeClr val="lt1"/>
+          </a:fontRef>
+        </p:style>
+        <p:txBody>
+          <a:bodyPr rtlCol="0" anchor="ctr"/>
+          <a:lstStyle/>
+          <a:p>
+            <a:pPr algn="ctr"/>
+          </a:p>
+        </p:txBody>
+      </p:sp>
+      <p:sp>
+        <p:nvSpPr>
+          <p:cNvPr id="22" name="TextBox 21"/>
+          <p:cNvSpPr txBox="1"/>
+          <p:nvPr/>
+        </p:nvSpPr>
+        <p:spPr>
+          <a:xfrm>
+            <a:off x="9372600" y="2148840"/>
+            <a:ext cx="2057400" cy="320040"/>
+          </a:xfrm>
+          <a:prstGeom prst="rect">
+            <a:avLst/>
+          </a:prstGeom>
+          <a:noFill/>
+        </p:spPr>
+        <p:txBody>
+          <a:bodyPr wrap="square">
+            <a:spAutoFit/>
+          </a:bodyPr>
+          <a:lstStyle/>
+          <a:p>
+            <a:pPr algn="ctr"/>
+            <a:r>
+              <a:rPr sz="1400" b="1">
+                <a:solidFill>
+                  <a:srgbClr val="122B40"/>
+                </a:solidFill>
+                <a:latin typeface="Aptos"/>
+              </a:rPr>
+              <a:t>Evaluation-Suite / Richter</a:t>
+            </a:r>
+          </a:p>
+        </p:txBody>
+      </p:sp>
+      <p:sp>
+        <p:nvSpPr>
+          <p:cNvPr id="23" name="TextBox 22"/>
+          <p:cNvSpPr txBox="1"/>
+          <p:nvPr/>
+        </p:nvSpPr>
+        <p:spPr>
+          <a:xfrm>
+            <a:off x="9372600" y="2697480"/>
+            <a:ext cx="2057400" cy="502920"/>
+          </a:xfrm>
+          <a:prstGeom prst="rect">
+            <a:avLst/>
+          </a:prstGeom>
+          <a:noFill/>
+        </p:spPr>
+        <p:txBody>
+          <a:bodyPr wrap="square">
+            <a:spAutoFit/>
+          </a:bodyPr>
+          <a:lstStyle/>
+          <a:p>
+            <a:pPr algn="ctr"/>
+            <a:r>
+              <a:rPr sz="1100" b="0">
+                <a:solidFill>
+                  <a:srgbClr val="202B36"/>
+                </a:solidFill>
+                <a:latin typeface="Aptos"/>
+              </a:rPr>
+              <a:t>unabhängige Qualitäts- und Sicherheitsbewertung</a:t>
+            </a:r>
+          </a:p>
+        </p:txBody>
+      </p:sp>
+      <p:sp>
+        <p:nvSpPr>
+          <p:cNvPr id="24" name="Rounded Rectangle 23"/>
+          <p:cNvSpPr/>
+          <p:nvPr/>
+        </p:nvSpPr>
+        <p:spPr>
+          <a:xfrm>
+            <a:off x="914400" y="4251960"/>
+            <a:ext cx="10241280" cy="914400"/>
+          </a:xfrm>
+          <a:prstGeom prst="roundRect">
+            <a:avLst/>
+          </a:prstGeom>
+          <a:solidFill>
+            <a:srgbClr val="122B40"/>
+          </a:solidFill>
+          <a:ln>
+            <a:solidFill>
+              <a:srgbClr val="122B40"/>
+            </a:solidFill>
+          </a:ln>
+        </p:spPr>
+        <p:style>
+          <a:lnRef idx="1">
+            <a:schemeClr val="accent1"/>
+          </a:lnRef>
+          <a:fillRef idx="3">
+            <a:schemeClr val="accent1"/>
+          </a:fillRef>
+          <a:effectRef idx="2">
+            <a:schemeClr val="accent1"/>
+          </a:effectRef>
+          <a:fontRef idx="minor">
+            <a:schemeClr val="lt1"/>
+          </a:fontRef>
+        </p:style>
+        <p:txBody>
+          <a:bodyPr rtlCol="0" anchor="ctr"/>
+          <a:lstStyle/>
+          <a:p>
+            <a:pPr algn="ctr"/>
+          </a:p>
+        </p:txBody>
+      </p:sp>
+      <p:sp>
+        <p:nvSpPr>
+          <p:cNvPr id="25" name="TextBox 24"/>
+          <p:cNvSpPr txBox="1"/>
+          <p:nvPr/>
+        </p:nvSpPr>
+        <p:spPr>
+          <a:xfrm>
+            <a:off x="1234440" y="4498848"/>
+            <a:ext cx="9601200" cy="256032"/>
+          </a:xfrm>
+          <a:prstGeom prst="rect">
+            <a:avLst/>
+          </a:prstGeom>
+          <a:noFill/>
+        </p:spPr>
+        <p:txBody>
+          <a:bodyPr wrap="square">
+            <a:spAutoFit/>
+          </a:bodyPr>
+          <a:lstStyle/>
+          <a:p>
+            <a:pPr algn="ctr"/>
+            <a:r>
+              <a:rPr sz="1600" b="1">
+                <a:solidFill>
+                  <a:srgbClr val="FFFFFF"/>
+                </a:solidFill>
+                <a:latin typeface="Aptos"/>
+              </a:rPr>
+              <a:t>Aktuell vorhanden: Harness + LLM/Gateway + technische Gates</a:t>
+            </a:r>
+          </a:p>
+        </p:txBody>
+      </p:sp>
+      <p:sp>
+        <p:nvSpPr>
+          <p:cNvPr id="26" name="TextBox 25"/>
+          <p:cNvSpPr txBox="1"/>
+          <p:nvPr/>
+        </p:nvSpPr>
+        <p:spPr>
+          <a:xfrm>
+            <a:off x="1234440" y="4828032"/>
+            <a:ext cx="9601200" cy="228600"/>
+          </a:xfrm>
+          <a:prstGeom prst="rect">
+            <a:avLst/>
+          </a:prstGeom>
+          <a:noFill/>
+        </p:spPr>
+        <p:txBody>
+          <a:bodyPr wrap="square">
+            <a:spAutoFit/>
+          </a:bodyPr>
+          <a:lstStyle/>
+          <a:p>
+            <a:pPr algn="ctr"/>
+            <a:r>
+              <a:rPr sz="1300" b="1">
+                <a:solidFill>
+                  <a:srgbClr val="FFDC82"/>
+                </a:solidFill>
+                <a:latin typeface="Aptos"/>
+              </a:rPr>
+              <a:t>Offen: Datensatz-Pipeline, unabhängige Evaluation/Richter und vollständiges Evidence Bundle</a:t>
             </a:r>
           </a:p>
         </p:txBody>

</xml_diff>

<commit_message>
docs: document PostgreSQL prompt registry
</commit_message>
<xml_diff>
--- a/Harness-System.pptx
+++ b/Harness-System.pptx
@@ -16,6 +16,7 @@
     <p:sldId id="261" r:id="rId7"/>
     <p:sldId id="262" r:id="rId13"/>
     <p:sldId id="263" r:id="rId14"/>
+    <p:sldId id="264" r:id="rId15"/>
   </p:sldIdLst>
   <p:sldSz cx="12192000" cy="6858000"/>
   <p:notesSz cx="6858000" cy="9144000"/>
@@ -1418,6 +1419,101 @@
 </p:notes>
 </file>
 
+<file path=ppt/notesSlides/notesSlide9.xml><?xml version="1.0" encoding="utf-8"?>
+<p:notes xmlns:a="http://schemas.openxmlformats.org/drawingml/2006/main" xmlns:p="http://schemas.openxmlformats.org/presentationml/2006/main" xmlns:r="http://schemas.openxmlformats.org/officeDocument/2006/relationships">
+  <p:cSld>
+    <p:spTree>
+      <p:nvGrpSpPr>
+        <p:cNvPr id="1" name=""/>
+        <p:cNvGrpSpPr/>
+        <p:nvPr/>
+      </p:nvGrpSpPr>
+      <p:grpSpPr>
+        <a:xfrm>
+          <a:off x="0" y="0"/>
+          <a:ext cx="0" cy="0"/>
+          <a:chOff x="0" y="0"/>
+          <a:chExt cx="0" cy="0"/>
+        </a:xfrm>
+      </p:grpSpPr>
+      <p:sp>
+        <p:nvSpPr>
+          <p:cNvPr id="2" name="Slide Image Placeholder 1"/>
+          <p:cNvSpPr>
+            <a:spLocks noGrp="1"/>
+          </p:cNvSpPr>
+          <p:nvPr>
+            <p:ph type="sldImg" idx="2"/>
+          </p:nvPr>
+        </p:nvSpPr>
+        <p:spPr/>
+      </p:sp>
+      <p:sp>
+        <p:nvSpPr>
+          <p:cNvPr id="3" name="Notes Placeholder 2"/>
+          <p:cNvSpPr>
+            <a:spLocks noGrp="1"/>
+          </p:cNvSpPr>
+          <p:nvPr>
+            <p:ph type="body" idx="3" sz="quarter"/>
+          </p:nvPr>
+        </p:nvSpPr>
+        <p:spPr/>
+        <p:txBody>
+          <a:bodyPr/>
+          <a:lstStyle/>
+          <a:p>
+            <a:r>
+              <a:t>Vortragshinweise</a:t>
+            </a:r>
+          </a:p>
+          <a:p>
+            <a:r>
+              <a:t>• Die Registry ist ein Referenzschema für den ersten PostgreSQL-Probelauf.</a:t>
+            </a:r>
+          </a:p>
+          <a:p>
+            <a:r>
+              <a:t>• Sie speichert Metadaten und Nachweise, nicht ungefilterte Prompt- oder Antwort-Rohdaten.</a:t>
+            </a:r>
+          </a:p>
+          <a:p>
+            <a:r>
+              <a:t>• Freigegebene Prompt-Versionen sind per Datenbanktrigger unveränderlich.</a:t>
+            </a:r>
+          </a:p>
+          <a:p>
+            <a:r>
+              <a:t>• Vor produktiver Nutzung fehlen noch TLS, Rollen, Backup, Restore, Retention und ein Registry-Service.</a:t>
+            </a:r>
+          </a:p>
+          <a:p>
+            <a:r>
+              <a:t>• Die Datenbank ersetzt weder rechtliche Bewertung noch menschliche Freigabe.</a:t>
+            </a:r>
+          </a:p>
+        </p:txBody>
+      </p:sp>
+      <p:sp>
+        <p:nvSpPr>
+          <p:cNvPr id="4" name="Slide Number Placeholder 3"/>
+          <p:cNvSpPr>
+            <a:spLocks noGrp="1"/>
+          </p:cNvSpPr>
+          <p:nvPr>
+            <p:ph type="sldNum" idx="5" sz="quarter"/>
+          </p:nvPr>
+        </p:nvSpPr>
+        <p:spPr/>
+      </p:sp>
+    </p:spTree>
+  </p:cSld>
+  <p:clrMapOvr>
+    <a:masterClrMapping/>
+  </p:clrMapOvr>
+</p:notes>
+</file>
+
 <file path=ppt/slideLayouts/slideLayout1.xml><?xml version="1.0" encoding="utf-8"?>
 <p:sldLayout xmlns:a="http://schemas.openxmlformats.org/drawingml/2006/main" xmlns:r="http://schemas.openxmlformats.org/officeDocument/2006/relationships" xmlns:p="http://schemas.openxmlformats.org/presentationml/2006/main" type="title" preserve="1">
   <p:cSld name="Title Slide">
@@ -10570,6 +10666,814 @@
                 <a:latin typeface="Aptos"/>
               </a:rPr>
               <a:t>Offen: Datensatz-Pipeline, unabhängige Evaluation/Richter und vollständiges Evidence Bundle</a:t>
+            </a:r>
+          </a:p>
+        </p:txBody>
+      </p:sp>
+    </p:spTree>
+  </p:cSld>
+  <p:clrMapOvr>
+    <a:masterClrMapping/>
+  </p:clrMapOvr>
+</p:sld>
+</file>
+
+<file path=ppt/slides/slide9.xml><?xml version="1.0" encoding="utf-8"?>
+<p:sld xmlns:a="http://schemas.openxmlformats.org/drawingml/2006/main" xmlns:p="http://schemas.openxmlformats.org/presentationml/2006/main" xmlns:r="http://schemas.openxmlformats.org/officeDocument/2006/relationships">
+  <p:cSld>
+    <p:spTree>
+      <p:nvGrpSpPr>
+        <p:cNvPr id="1" name=""/>
+        <p:cNvGrpSpPr/>
+        <p:nvPr/>
+      </p:nvGrpSpPr>
+      <p:grpSpPr/>
+      <p:sp>
+        <p:nvSpPr>
+          <p:cNvPr id="2" name="Rectangle 1"/>
+          <p:cNvSpPr/>
+          <p:nvPr/>
+        </p:nvSpPr>
+        <p:spPr>
+          <a:xfrm>
+            <a:off x="0" y="0"/>
+            <a:ext cx="12191695" cy="146304"/>
+          </a:xfrm>
+          <a:prstGeom prst="rect">
+            <a:avLst/>
+          </a:prstGeom>
+          <a:solidFill>
+            <a:srgbClr val="206991"/>
+          </a:solidFill>
+          <a:ln>
+            <a:solidFill>
+              <a:srgbClr val="206991"/>
+            </a:solidFill>
+          </a:ln>
+        </p:spPr>
+        <p:style>
+          <a:lnRef idx="1">
+            <a:schemeClr val="accent1"/>
+          </a:lnRef>
+          <a:fillRef idx="3">
+            <a:schemeClr val="accent1"/>
+          </a:fillRef>
+          <a:effectRef idx="2">
+            <a:schemeClr val="accent1"/>
+          </a:effectRef>
+          <a:fontRef idx="minor">
+            <a:schemeClr val="lt1"/>
+          </a:fontRef>
+        </p:style>
+        <p:txBody>
+          <a:bodyPr rtlCol="0" anchor="ctr"/>
+          <a:lstStyle/>
+          <a:p>
+            <a:pPr algn="ctr"/>
+          </a:p>
+        </p:txBody>
+      </p:sp>
+      <p:sp>
+        <p:nvSpPr>
+          <p:cNvPr id="3" name="TextBox 2"/>
+          <p:cNvSpPr txBox="1"/>
+          <p:nvPr/>
+        </p:nvSpPr>
+        <p:spPr>
+          <a:xfrm>
+            <a:off x="594360" y="347472"/>
+            <a:ext cx="2743200" cy="228600"/>
+          </a:xfrm>
+          <a:prstGeom prst="rect">
+            <a:avLst/>
+          </a:prstGeom>
+          <a:noFill/>
+        </p:spPr>
+        <p:txBody>
+          <a:bodyPr wrap="square">
+            <a:spAutoFit/>
+          </a:bodyPr>
+          <a:lstStyle/>
+          <a:p>
+            <a:pPr algn="l"/>
+            <a:r>
+              <a:rPr sz="1000" b="1">
+                <a:solidFill>
+                  <a:srgbClr val="206991"/>
+                </a:solidFill>
+                <a:latin typeface="Aptos"/>
+              </a:rPr>
+              <a:t>PROMPT-REGISTRY</a:t>
+            </a:r>
+          </a:p>
+        </p:txBody>
+      </p:sp>
+      <p:sp>
+        <p:nvSpPr>
+          <p:cNvPr id="4" name="TextBox 3"/>
+          <p:cNvSpPr txBox="1"/>
+          <p:nvPr/>
+        </p:nvSpPr>
+        <p:spPr>
+          <a:xfrm>
+            <a:off x="594360" y="658368"/>
+            <a:ext cx="10515600" cy="548640"/>
+          </a:xfrm>
+          <a:prstGeom prst="rect">
+            <a:avLst/>
+          </a:prstGeom>
+          <a:noFill/>
+        </p:spPr>
+        <p:txBody>
+          <a:bodyPr wrap="square">
+            <a:spAutoFit/>
+          </a:bodyPr>
+          <a:lstStyle/>
+          <a:p>
+            <a:pPr algn="l"/>
+            <a:r>
+              <a:rPr sz="2700" b="1">
+                <a:solidFill>
+                  <a:srgbClr val="122B40"/>
+                </a:solidFill>
+                <a:latin typeface="Aptos"/>
+              </a:rPr>
+              <a:t>PostgreSQL als Nachweis- und Versionsspeicher</a:t>
+            </a:r>
+          </a:p>
+        </p:txBody>
+      </p:sp>
+      <p:sp>
+        <p:nvSpPr>
+          <p:cNvPr id="5" name="Rounded Rectangle 4"/>
+          <p:cNvSpPr/>
+          <p:nvPr/>
+        </p:nvSpPr>
+        <p:spPr>
+          <a:xfrm>
+            <a:off x="777240" y="1828800"/>
+            <a:ext cx="3154680" cy="1417320"/>
+          </a:xfrm>
+          <a:prstGeom prst="roundRect">
+            <a:avLst/>
+          </a:prstGeom>
+          <a:solidFill>
+            <a:srgbClr val="EFF5F7"/>
+          </a:solidFill>
+          <a:ln>
+            <a:solidFill>
+              <a:srgbClr val="EFF5F7"/>
+            </a:solidFill>
+          </a:ln>
+        </p:spPr>
+        <p:style>
+          <a:lnRef idx="1">
+            <a:schemeClr val="accent1"/>
+          </a:lnRef>
+          <a:fillRef idx="3">
+            <a:schemeClr val="accent1"/>
+          </a:fillRef>
+          <a:effectRef idx="2">
+            <a:schemeClr val="accent1"/>
+          </a:effectRef>
+          <a:fontRef idx="minor">
+            <a:schemeClr val="lt1"/>
+          </a:fontRef>
+        </p:style>
+        <p:txBody>
+          <a:bodyPr rtlCol="0" anchor="ctr"/>
+          <a:lstStyle/>
+          <a:p>
+            <a:pPr algn="ctr"/>
+          </a:p>
+        </p:txBody>
+      </p:sp>
+      <p:sp>
+        <p:nvSpPr>
+          <p:cNvPr id="6" name="Rectangle 5"/>
+          <p:cNvSpPr/>
+          <p:nvPr/>
+        </p:nvSpPr>
+        <p:spPr>
+          <a:xfrm>
+            <a:off x="777240" y="1828800"/>
+            <a:ext cx="3154680" cy="109728"/>
+          </a:xfrm>
+          <a:prstGeom prst="rect">
+            <a:avLst/>
+          </a:prstGeom>
+          <a:solidFill>
+            <a:srgbClr val="206991"/>
+          </a:solidFill>
+          <a:ln>
+            <a:solidFill>
+              <a:srgbClr val="206991"/>
+            </a:solidFill>
+          </a:ln>
+        </p:spPr>
+        <p:style>
+          <a:lnRef idx="1">
+            <a:schemeClr val="accent1"/>
+          </a:lnRef>
+          <a:fillRef idx="3">
+            <a:schemeClr val="accent1"/>
+          </a:fillRef>
+          <a:effectRef idx="2">
+            <a:schemeClr val="accent1"/>
+          </a:effectRef>
+          <a:fontRef idx="minor">
+            <a:schemeClr val="lt1"/>
+          </a:fontRef>
+        </p:style>
+        <p:txBody>
+          <a:bodyPr rtlCol="0" anchor="ctr"/>
+          <a:lstStyle/>
+          <a:p>
+            <a:pPr algn="ctr"/>
+          </a:p>
+        </p:txBody>
+      </p:sp>
+      <p:sp>
+        <p:nvSpPr>
+          <p:cNvPr id="7" name="TextBox 6"/>
+          <p:cNvSpPr txBox="1"/>
+          <p:nvPr/>
+        </p:nvSpPr>
+        <p:spPr>
+          <a:xfrm>
+            <a:off x="1005840" y="2148840"/>
+            <a:ext cx="2651760" cy="274320"/>
+          </a:xfrm>
+          <a:prstGeom prst="rect">
+            <a:avLst/>
+          </a:prstGeom>
+          <a:noFill/>
+        </p:spPr>
+        <p:txBody>
+          <a:bodyPr wrap="square">
+            <a:spAutoFit/>
+          </a:bodyPr>
+          <a:lstStyle/>
+          <a:p>
+            <a:pPr algn="ctr"/>
+            <a:r>
+              <a:rPr sz="1600" b="1">
+                <a:solidFill>
+                  <a:srgbClr val="122B40"/>
+                </a:solidFill>
+                <a:latin typeface="Aptos"/>
+              </a:rPr>
+              <a:t>Registry</a:t>
+            </a:r>
+          </a:p>
+        </p:txBody>
+      </p:sp>
+      <p:sp>
+        <p:nvSpPr>
+          <p:cNvPr id="8" name="TextBox 7"/>
+          <p:cNvSpPr txBox="1"/>
+          <p:nvPr/>
+        </p:nvSpPr>
+        <p:spPr>
+          <a:xfrm>
+            <a:off x="1005840" y="2633472"/>
+            <a:ext cx="2651760" cy="411480"/>
+          </a:xfrm>
+          <a:prstGeom prst="rect">
+            <a:avLst/>
+          </a:prstGeom>
+          <a:noFill/>
+        </p:spPr>
+        <p:txBody>
+          <a:bodyPr wrap="square">
+            <a:spAutoFit/>
+          </a:bodyPr>
+          <a:lstStyle/>
+          <a:p>
+            <a:pPr algn="ctr"/>
+            <a:r>
+              <a:rPr sz="1200" b="0">
+                <a:solidFill>
+                  <a:srgbClr val="202B36"/>
+                </a:solidFill>
+                <a:latin typeface="Aptos"/>
+              </a:rPr>
+              <a:t>Prompt-Versionen, Modellprovenienz und Freigaben</a:t>
+            </a:r>
+          </a:p>
+        </p:txBody>
+      </p:sp>
+      <p:sp>
+        <p:nvSpPr>
+          <p:cNvPr id="9" name="Rounded Rectangle 8"/>
+          <p:cNvSpPr/>
+          <p:nvPr/>
+        </p:nvSpPr>
+        <p:spPr>
+          <a:xfrm>
+            <a:off x="4526279" y="1828800"/>
+            <a:ext cx="3154680" cy="1417320"/>
+          </a:xfrm>
+          <a:prstGeom prst="roundRect">
+            <a:avLst/>
+          </a:prstGeom>
+          <a:solidFill>
+            <a:srgbClr val="EFF5F7"/>
+          </a:solidFill>
+          <a:ln>
+            <a:solidFill>
+              <a:srgbClr val="EFF5F7"/>
+            </a:solidFill>
+          </a:ln>
+        </p:spPr>
+        <p:style>
+          <a:lnRef idx="1">
+            <a:schemeClr val="accent1"/>
+          </a:lnRef>
+          <a:fillRef idx="3">
+            <a:schemeClr val="accent1"/>
+          </a:fillRef>
+          <a:effectRef idx="2">
+            <a:schemeClr val="accent1"/>
+          </a:effectRef>
+          <a:fontRef idx="minor">
+            <a:schemeClr val="lt1"/>
+          </a:fontRef>
+        </p:style>
+        <p:txBody>
+          <a:bodyPr rtlCol="0" anchor="ctr"/>
+          <a:lstStyle/>
+          <a:p>
+            <a:pPr algn="ctr"/>
+          </a:p>
+        </p:txBody>
+      </p:sp>
+      <p:sp>
+        <p:nvSpPr>
+          <p:cNvPr id="10" name="Rectangle 9"/>
+          <p:cNvSpPr/>
+          <p:nvPr/>
+        </p:nvSpPr>
+        <p:spPr>
+          <a:xfrm>
+            <a:off x="4526279" y="1828800"/>
+            <a:ext cx="3154680" cy="109728"/>
+          </a:xfrm>
+          <a:prstGeom prst="rect">
+            <a:avLst/>
+          </a:prstGeom>
+          <a:solidFill>
+            <a:srgbClr val="00897B"/>
+          </a:solidFill>
+          <a:ln>
+            <a:solidFill>
+              <a:srgbClr val="00897B"/>
+            </a:solidFill>
+          </a:ln>
+        </p:spPr>
+        <p:style>
+          <a:lnRef idx="1">
+            <a:schemeClr val="accent1"/>
+          </a:lnRef>
+          <a:fillRef idx="3">
+            <a:schemeClr val="accent1"/>
+          </a:fillRef>
+          <a:effectRef idx="2">
+            <a:schemeClr val="accent1"/>
+          </a:effectRef>
+          <a:fontRef idx="minor">
+            <a:schemeClr val="lt1"/>
+          </a:fontRef>
+        </p:style>
+        <p:txBody>
+          <a:bodyPr rtlCol="0" anchor="ctr"/>
+          <a:lstStyle/>
+          <a:p>
+            <a:pPr algn="ctr"/>
+          </a:p>
+        </p:txBody>
+      </p:sp>
+      <p:sp>
+        <p:nvSpPr>
+          <p:cNvPr id="11" name="TextBox 10"/>
+          <p:cNvSpPr txBox="1"/>
+          <p:nvPr/>
+        </p:nvSpPr>
+        <p:spPr>
+          <a:xfrm>
+            <a:off x="4754879" y="2148840"/>
+            <a:ext cx="2651760" cy="274320"/>
+          </a:xfrm>
+          <a:prstGeom prst="rect">
+            <a:avLst/>
+          </a:prstGeom>
+          <a:noFill/>
+        </p:spPr>
+        <p:txBody>
+          <a:bodyPr wrap="square">
+            <a:spAutoFit/>
+          </a:bodyPr>
+          <a:lstStyle/>
+          <a:p>
+            <a:pPr algn="ctr"/>
+            <a:r>
+              <a:rPr sz="1600" b="1">
+                <a:solidFill>
+                  <a:srgbClr val="122B40"/>
+                </a:solidFill>
+                <a:latin typeface="Aptos"/>
+              </a:rPr>
+              <a:t>Evaluation</a:t>
+            </a:r>
+          </a:p>
+        </p:txBody>
+      </p:sp>
+      <p:sp>
+        <p:nvSpPr>
+          <p:cNvPr id="12" name="TextBox 11"/>
+          <p:cNvSpPr txBox="1"/>
+          <p:nvPr/>
+        </p:nvSpPr>
+        <p:spPr>
+          <a:xfrm>
+            <a:off x="4754879" y="2633472"/>
+            <a:ext cx="2651760" cy="411480"/>
+          </a:xfrm>
+          <a:prstGeom prst="rect">
+            <a:avLst/>
+          </a:prstGeom>
+          <a:noFill/>
+        </p:spPr>
+        <p:txBody>
+          <a:bodyPr wrap="square">
+            <a:spAutoFit/>
+          </a:bodyPr>
+          <a:lstStyle/>
+          <a:p>
+            <a:pPr algn="ctr"/>
+            <a:r>
+              <a:rPr sz="1200" b="0">
+                <a:solidFill>
+                  <a:srgbClr val="202B36"/>
+                </a:solidFill>
+                <a:latin typeface="Aptos"/>
+              </a:rPr>
+              <a:t>Datasets, Testfälle, Runs und unabhängige Richtergebnisse</a:t>
+            </a:r>
+          </a:p>
+        </p:txBody>
+      </p:sp>
+      <p:sp>
+        <p:nvSpPr>
+          <p:cNvPr id="13" name="Rounded Rectangle 12"/>
+          <p:cNvSpPr/>
+          <p:nvPr/>
+        </p:nvSpPr>
+        <p:spPr>
+          <a:xfrm>
+            <a:off x="8275319" y="1828800"/>
+            <a:ext cx="3154680" cy="1417320"/>
+          </a:xfrm>
+          <a:prstGeom prst="roundRect">
+            <a:avLst/>
+          </a:prstGeom>
+          <a:solidFill>
+            <a:srgbClr val="EFF5F7"/>
+          </a:solidFill>
+          <a:ln>
+            <a:solidFill>
+              <a:srgbClr val="EFF5F7"/>
+            </a:solidFill>
+          </a:ln>
+        </p:spPr>
+        <p:style>
+          <a:lnRef idx="1">
+            <a:schemeClr val="accent1"/>
+          </a:lnRef>
+          <a:fillRef idx="3">
+            <a:schemeClr val="accent1"/>
+          </a:fillRef>
+          <a:effectRef idx="2">
+            <a:schemeClr val="accent1"/>
+          </a:effectRef>
+          <a:fontRef idx="minor">
+            <a:schemeClr val="lt1"/>
+          </a:fontRef>
+        </p:style>
+        <p:txBody>
+          <a:bodyPr rtlCol="0" anchor="ctr"/>
+          <a:lstStyle/>
+          <a:p>
+            <a:pPr algn="ctr"/>
+          </a:p>
+        </p:txBody>
+      </p:sp>
+      <p:sp>
+        <p:nvSpPr>
+          <p:cNvPr id="14" name="Rectangle 13"/>
+          <p:cNvSpPr/>
+          <p:nvPr/>
+        </p:nvSpPr>
+        <p:spPr>
+          <a:xfrm>
+            <a:off x="8275319" y="1828800"/>
+            <a:ext cx="3154680" cy="109728"/>
+          </a:xfrm>
+          <a:prstGeom prst="rect">
+            <a:avLst/>
+          </a:prstGeom>
+          <a:solidFill>
+            <a:srgbClr val="DA9420"/>
+          </a:solidFill>
+          <a:ln>
+            <a:solidFill>
+              <a:srgbClr val="DA9420"/>
+            </a:solidFill>
+          </a:ln>
+        </p:spPr>
+        <p:style>
+          <a:lnRef idx="1">
+            <a:schemeClr val="accent1"/>
+          </a:lnRef>
+          <a:fillRef idx="3">
+            <a:schemeClr val="accent1"/>
+          </a:fillRef>
+          <a:effectRef idx="2">
+            <a:schemeClr val="accent1"/>
+          </a:effectRef>
+          <a:fontRef idx="minor">
+            <a:schemeClr val="lt1"/>
+          </a:fontRef>
+        </p:style>
+        <p:txBody>
+          <a:bodyPr rtlCol="0" anchor="ctr"/>
+          <a:lstStyle/>
+          <a:p>
+            <a:pPr algn="ctr"/>
+          </a:p>
+        </p:txBody>
+      </p:sp>
+      <p:sp>
+        <p:nvSpPr>
+          <p:cNvPr id="15" name="TextBox 14"/>
+          <p:cNvSpPr txBox="1"/>
+          <p:nvPr/>
+        </p:nvSpPr>
+        <p:spPr>
+          <a:xfrm>
+            <a:off x="8503919" y="2148840"/>
+            <a:ext cx="2651760" cy="274320"/>
+          </a:xfrm>
+          <a:prstGeom prst="rect">
+            <a:avLst/>
+          </a:prstGeom>
+          <a:noFill/>
+        </p:spPr>
+        <p:txBody>
+          <a:bodyPr wrap="square">
+            <a:spAutoFit/>
+          </a:bodyPr>
+          <a:lstStyle/>
+          <a:p>
+            <a:pPr algn="ctr"/>
+            <a:r>
+              <a:rPr sz="1600" b="1">
+                <a:solidFill>
+                  <a:srgbClr val="122B40"/>
+                </a:solidFill>
+                <a:latin typeface="Aptos"/>
+              </a:rPr>
+              <a:t>Evidence</a:t>
+            </a:r>
+          </a:p>
+        </p:txBody>
+      </p:sp>
+      <p:sp>
+        <p:nvSpPr>
+          <p:cNvPr id="16" name="TextBox 15"/>
+          <p:cNvSpPr txBox="1"/>
+          <p:nvPr/>
+        </p:nvSpPr>
+        <p:spPr>
+          <a:xfrm>
+            <a:off x="8503919" y="2633472"/>
+            <a:ext cx="2651760" cy="411480"/>
+          </a:xfrm>
+          <a:prstGeom prst="rect">
+            <a:avLst/>
+          </a:prstGeom>
+          <a:noFill/>
+        </p:spPr>
+        <p:txBody>
+          <a:bodyPr wrap="square">
+            <a:spAutoFit/>
+          </a:bodyPr>
+          <a:lstStyle/>
+          <a:p>
+            <a:pPr algn="ctr"/>
+            <a:r>
+              <a:rPr sz="1200" b="0">
+                <a:solidFill>
+                  <a:srgbClr val="202B36"/>
+                </a:solidFill>
+                <a:latin typeface="Aptos"/>
+              </a:rPr>
+              <a:t>Hashes, Retention, Audit-Ereignisse und Freigabe</a:t>
+            </a:r>
+          </a:p>
+        </p:txBody>
+      </p:sp>
+      <p:sp>
+        <p:nvSpPr>
+          <p:cNvPr id="17" name="Rounded Rectangle 16"/>
+          <p:cNvSpPr/>
+          <p:nvPr/>
+        </p:nvSpPr>
+        <p:spPr>
+          <a:xfrm>
+            <a:off x="822960" y="3977639"/>
+            <a:ext cx="10515600" cy="1234440"/>
+          </a:xfrm>
+          <a:prstGeom prst="roundRect">
+            <a:avLst/>
+          </a:prstGeom>
+          <a:solidFill>
+            <a:srgbClr val="122B40"/>
+          </a:solidFill>
+          <a:ln>
+            <a:solidFill>
+              <a:srgbClr val="122B40"/>
+            </a:solidFill>
+          </a:ln>
+        </p:spPr>
+        <p:style>
+          <a:lnRef idx="1">
+            <a:schemeClr val="accent1"/>
+          </a:lnRef>
+          <a:fillRef idx="3">
+            <a:schemeClr val="accent1"/>
+          </a:fillRef>
+          <a:effectRef idx="2">
+            <a:schemeClr val="accent1"/>
+          </a:effectRef>
+          <a:fontRef idx="minor">
+            <a:schemeClr val="lt1"/>
+          </a:fontRef>
+        </p:style>
+        <p:txBody>
+          <a:bodyPr rtlCol="0" anchor="ctr"/>
+          <a:lstStyle/>
+          <a:p>
+            <a:pPr algn="ctr"/>
+          </a:p>
+        </p:txBody>
+      </p:sp>
+      <p:sp>
+        <p:nvSpPr>
+          <p:cNvPr id="18" name="TextBox 17"/>
+          <p:cNvSpPr txBox="1"/>
+          <p:nvPr/>
+        </p:nvSpPr>
+        <p:spPr>
+          <a:xfrm>
+            <a:off x="1143000" y="4251960"/>
+            <a:ext cx="1920240" cy="228600"/>
+          </a:xfrm>
+          <a:prstGeom prst="rect">
+            <a:avLst/>
+          </a:prstGeom>
+          <a:noFill/>
+        </p:spPr>
+        <p:txBody>
+          <a:bodyPr wrap="square">
+            <a:spAutoFit/>
+          </a:bodyPr>
+          <a:lstStyle/>
+          <a:p>
+            <a:pPr algn="l"/>
+            <a:r>
+              <a:rPr sz="1400" b="1">
+                <a:solidFill>
+                  <a:srgbClr val="DA9420"/>
+                </a:solidFill>
+                <a:latin typeface="Aptos"/>
+              </a:rPr>
+              <a:t>Sicherheitsgrenzen</a:t>
+            </a:r>
+          </a:p>
+        </p:txBody>
+      </p:sp>
+      <p:sp>
+        <p:nvSpPr>
+          <p:cNvPr id="19" name="TextBox 18"/>
+          <p:cNvSpPr txBox="1"/>
+          <p:nvPr/>
+        </p:nvSpPr>
+        <p:spPr>
+          <a:xfrm>
+            <a:off x="3154680" y="4187952"/>
+            <a:ext cx="7680960" cy="457200"/>
+          </a:xfrm>
+          <a:prstGeom prst="rect">
+            <a:avLst/>
+          </a:prstGeom>
+          <a:noFill/>
+        </p:spPr>
+        <p:txBody>
+          <a:bodyPr wrap="square">
+            <a:spAutoFit/>
+          </a:bodyPr>
+          <a:lstStyle/>
+          <a:p>
+            <a:pPr algn="l"/>
+            <a:r>
+              <a:rPr sz="1500" b="1">
+                <a:solidFill>
+                  <a:srgbClr val="FFFFFF"/>
+                </a:solidFill>
+                <a:latin typeface="Aptos"/>
+              </a:rPr>
+              <a:t>LLM ohne DB-Zugriff • approved-Versionen unveränderlich • keine Roh-Prompts • PII-/Secret-Scan vor Evidence</a:t>
+            </a:r>
+          </a:p>
+        </p:txBody>
+      </p:sp>
+      <p:sp>
+        <p:nvSpPr>
+          <p:cNvPr id="20" name="Rounded Rectangle 19"/>
+          <p:cNvSpPr/>
+          <p:nvPr/>
+        </p:nvSpPr>
+        <p:spPr>
+          <a:xfrm>
+            <a:off x="822960" y="5486400"/>
+            <a:ext cx="10515600" cy="594360"/>
+          </a:xfrm>
+          <a:prstGeom prst="roundRect">
+            <a:avLst/>
+          </a:prstGeom>
+          <a:solidFill>
+            <a:srgbClr val="B23E3E"/>
+          </a:solidFill>
+          <a:ln>
+            <a:solidFill>
+              <a:srgbClr val="B23E3E"/>
+            </a:solidFill>
+          </a:ln>
+        </p:spPr>
+        <p:style>
+          <a:lnRef idx="1">
+            <a:schemeClr val="accent1"/>
+          </a:lnRef>
+          <a:fillRef idx="3">
+            <a:schemeClr val="accent1"/>
+          </a:fillRef>
+          <a:effectRef idx="2">
+            <a:schemeClr val="accent1"/>
+          </a:effectRef>
+          <a:fontRef idx="minor">
+            <a:schemeClr val="lt1"/>
+          </a:fontRef>
+        </p:style>
+        <p:txBody>
+          <a:bodyPr rtlCol="0" anchor="ctr"/>
+          <a:lstStyle/>
+          <a:p>
+            <a:pPr algn="ctr"/>
+          </a:p>
+        </p:txBody>
+      </p:sp>
+      <p:sp>
+        <p:nvSpPr>
+          <p:cNvPr id="21" name="TextBox 20"/>
+          <p:cNvSpPr txBox="1"/>
+          <p:nvPr/>
+        </p:nvSpPr>
+        <p:spPr>
+          <a:xfrm>
+            <a:off x="1051560" y="5669280"/>
+            <a:ext cx="10058400" cy="201168"/>
+          </a:xfrm>
+          <a:prstGeom prst="rect">
+            <a:avLst/>
+          </a:prstGeom>
+          <a:noFill/>
+        </p:spPr>
+        <p:txBody>
+          <a:bodyPr wrap="square">
+            <a:spAutoFit/>
+          </a:bodyPr>
+          <a:lstStyle/>
+          <a:p>
+            <a:pPr algn="ctr"/>
+            <a:r>
+              <a:rPr sz="1200" b="1">
+                <a:solidFill>
+                  <a:srgbClr val="FFFFFF"/>
+                </a:solidFill>
+                <a:latin typeface="Aptos"/>
+              </a:rPr>
+              <a:t>ToDo: minimale DB-Rolle, PostgreSQL-TLS, Backup/Restore, Registry-Service und Harness-/Evaluation-Integration</a:t>
             </a:r>
           </a:p>
         </p:txBody>

</xml_diff>